<commit_message>
feat: added application structure; doc: updated pitchdeck
</commit_message>
<xml_diff>
--- a/project_documents/pitch_deck_cinematch.pptx
+++ b/project_documents/pitch_deck_cinematch.pptx
@@ -16810,7 +16810,7 @@
             <a:pPr rtl="0"/>
             <a:fld id="{705D51D2-ADCD-4092-BFAC-B3B920D83F85}" type="datetime1">
               <a:rPr lang="de-DE" smtClean="0"/>
-              <a:t>05.04.2026</a:t>
+              <a:t>06.04.2026</a:t>
             </a:fld>
             <a:endParaRPr lang="de-DE" dirty="0"/>
           </a:p>
@@ -16979,7 +16979,7 @@
             <a:fld id="{253EE615-04DF-4142-8B33-EF0FCE4F93E5}" type="datetime1">
               <a:rPr lang="de-DE" smtClean="0"/>
               <a:pPr/>
-              <a:t>05.04.2026</a:t>
+              <a:t>06.04.2026</a:t>
             </a:fld>
             <a:endParaRPr lang="de-DE" dirty="0"/>
           </a:p>
@@ -17616,7 +17616,7 @@
             <a:pPr rtl="0"/>
             <a:fld id="{88FC6F8F-5002-4D94-A3C0-B6AB2DF62D27}" type="datetime1">
               <a:rPr lang="de-DE" noProof="0" smtClean="0"/>
-              <a:t>05.04.2026</a:t>
+              <a:t>06.04.2026</a:t>
             </a:fld>
             <a:endParaRPr lang="de-DE" noProof="0" dirty="0"/>
           </a:p>
@@ -17822,7 +17822,7 @@
             <a:pPr rtl="0"/>
             <a:fld id="{8FFF26CF-3A7C-4631-A8BF-38458B0B5AD3}" type="datetime1">
               <a:rPr lang="de-DE" noProof="0" smtClean="0"/>
-              <a:t>05.04.2026</a:t>
+              <a:t>06.04.2026</a:t>
             </a:fld>
             <a:endParaRPr lang="de-DE" noProof="0" dirty="0"/>
           </a:p>
@@ -18001,7 +18001,7 @@
             <a:pPr rtl="0"/>
             <a:fld id="{5656F5FC-E12D-4883-A900-D8F749C16886}" type="datetime1">
               <a:rPr lang="de-DE" noProof="0" smtClean="0"/>
-              <a:t>05.04.2026</a:t>
+              <a:t>06.04.2026</a:t>
             </a:fld>
             <a:endParaRPr lang="de-DE" noProof="0" dirty="0"/>
           </a:p>
@@ -18205,7 +18205,7 @@
             <a:pPr rtl="0"/>
             <a:fld id="{AD11D247-BF25-4313-848F-0A6FFDC42CC3}" type="datetime1">
               <a:rPr lang="de-DE" noProof="0" smtClean="0"/>
-              <a:t>05.04.2026</a:t>
+              <a:t>06.04.2026</a:t>
             </a:fld>
             <a:endParaRPr lang="de-DE" noProof="0" dirty="0"/>
           </a:p>
@@ -27102,7 +27102,7 @@
             <a:pPr rtl="0"/>
             <a:fld id="{043CEAD4-1021-4B35-8BEC-0363D8DA6A57}" type="datetime1">
               <a:rPr lang="de-DE" noProof="0" smtClean="0"/>
-              <a:t>05.04.2026</a:t>
+              <a:t>06.04.2026</a:t>
             </a:fld>
             <a:endParaRPr lang="de-DE" noProof="0" dirty="0"/>
           </a:p>
@@ -27375,7 +27375,7 @@
             <a:pPr rtl="0"/>
             <a:fld id="{BE0DE884-BDB3-4445-9C7C-427638C7C80D}" type="datetime1">
               <a:rPr lang="de-DE" noProof="0" smtClean="0"/>
-              <a:t>05.04.2026</a:t>
+              <a:t>06.04.2026</a:t>
             </a:fld>
             <a:endParaRPr lang="de-DE" noProof="0" dirty="0"/>
           </a:p>
@@ -27771,7 +27771,7 @@
             <a:pPr rtl="0"/>
             <a:fld id="{24235473-FEB4-4673-9FA8-147CB48494B0}" type="datetime1">
               <a:rPr lang="de-DE" noProof="0" smtClean="0"/>
-              <a:t>05.04.2026</a:t>
+              <a:t>06.04.2026</a:t>
             </a:fld>
             <a:endParaRPr lang="de-DE" noProof="0" dirty="0"/>
           </a:p>
@@ -27888,7 +27888,7 @@
             <a:pPr rtl="0"/>
             <a:fld id="{DB72DBD2-9956-48DD-B433-972316F0D390}" type="datetime1">
               <a:rPr lang="de-DE" noProof="0" smtClean="0"/>
-              <a:t>05.04.2026</a:t>
+              <a:t>06.04.2026</a:t>
             </a:fld>
             <a:endParaRPr lang="de-DE" noProof="0" dirty="0"/>
           </a:p>
@@ -27981,7 +27981,7 @@
             <a:pPr rtl="0"/>
             <a:fld id="{7E7600A1-B4CA-4F63-8D09-F7DBA6E64CEA}" type="datetime1">
               <a:rPr lang="de-DE" noProof="0" smtClean="0"/>
-              <a:t>05.04.2026</a:t>
+              <a:t>06.04.2026</a:t>
             </a:fld>
             <a:endParaRPr lang="de-DE" noProof="0" dirty="0"/>
           </a:p>
@@ -28270,7 +28270,7 @@
             <a:pPr rtl="0"/>
             <a:fld id="{E723E022-A1A1-4E4C-B902-14F8D62BE84E}" type="datetime1">
               <a:rPr lang="de-DE" noProof="0" smtClean="0"/>
-              <a:t>05.04.2026</a:t>
+              <a:t>06.04.2026</a:t>
             </a:fld>
             <a:endParaRPr lang="de-DE" noProof="0" dirty="0"/>
           </a:p>
@@ -28550,7 +28550,7 @@
             <a:pPr rtl="0"/>
             <a:fld id="{01FB6D58-F84C-4882-B265-0A468AAE9816}" type="datetime1">
               <a:rPr lang="de-DE" noProof="0" smtClean="0"/>
-              <a:t>05.04.2026</a:t>
+              <a:t>06.04.2026</a:t>
             </a:fld>
             <a:endParaRPr lang="de-DE" noProof="0" dirty="0"/>
           </a:p>
@@ -28797,7 +28797,7 @@
             <a:pPr rtl="0"/>
             <a:fld id="{9E3617B5-9D3A-4290-B029-5215CF6190BB}" type="datetime1">
               <a:rPr lang="de-DE" noProof="0" smtClean="0"/>
-              <a:t>05.04.2026</a:t>
+              <a:t>06.04.2026</a:t>
             </a:fld>
             <a:endParaRPr lang="de-DE" noProof="0" dirty="0"/>
           </a:p>
@@ -30013,24 +30013,14 @@
               <a:t>The data was sourced from </a:t>
             </a:r>
             <a:r>
-              <a:rPr lang="en-GB" dirty="0">
-                <a:highlight>
-                  <a:srgbClr val="FFFF00"/>
-                </a:highlight>
+              <a:rPr lang="en-US" dirty="0" err="1">
+                <a:hlinkClick r:id="rId2" tooltip="https://files.grouplens.org/datasets/movielens/"/>
               </a:rPr>
-              <a:t>[SOURCE]</a:t>
+              <a:t>Movielens</a:t>
             </a:r>
             <a:r>
               <a:rPr lang="en-GB" dirty="0"/>
-              <a:t> as a csv and will be stored in a </a:t>
-            </a:r>
-            <a:r>
-              <a:rPr lang="en-GB" dirty="0" err="1"/>
-              <a:t>Postgresql</a:t>
-            </a:r>
-            <a:r>
-              <a:rPr lang="en-GB" dirty="0"/>
-              <a:t> database for better access.</a:t>
+              <a:t> as a csv and will be stored in a PostgreSQL database for better access.</a:t>
             </a:r>
           </a:p>
         </p:txBody>
@@ -30735,7 +30725,11 @@
           <a:p>
             <a:r>
               <a:rPr lang="en-GB" dirty="0"/>
-              <a:t>Tools – Backend</a:t>
+              <a:t>Tools – </a:t>
+            </a:r>
+            <a:r>
+              <a:rPr lang="en-GB" dirty="0" err="1"/>
+              <a:t>Devops</a:t>
             </a:r>
             <a:endParaRPr lang="de-DE" dirty="0"/>
           </a:p>

</xml_diff>

<commit_message>
docu: smol change to presentation
</commit_message>
<xml_diff>
--- a/project_documents/pitch_deck_cinematch.pptx
+++ b/project_documents/pitch_deck_cinematch.pptx
@@ -5435,7 +5435,7 @@
         <a:p>
           <a:r>
             <a:rPr lang="en-GB" dirty="0"/>
-            <a:t>Storing, loading and running the GNN for inference during application runtime</a:t>
+            <a:t>Storing, loading and running the GNN for inference during application runtime (inference)</a:t>
           </a:r>
         </a:p>
       </dgm:t>
@@ -5471,7 +5471,7 @@
         <a:p>
           <a:r>
             <a:rPr lang="en-GB" dirty="0"/>
-            <a:t>Schedule, running and tracking the GNN training runs and hyperparameter optimization</a:t>
+            <a:t>Schedule, running and tracking the GNN training runs and hyperparameter optimization to improve the model</a:t>
           </a:r>
         </a:p>
       </dgm:t>
@@ -5709,7 +5709,7 @@
         <a:p>
           <a:r>
             <a:rPr lang="en-GB" dirty="0"/>
-            <a:t>In order to access the needed data, the existing CSV-file is converted and stored in a RDBMS</a:t>
+            <a:t>In order to access the needed data from the application during inference, the existing CSV-file is converted and stored in a RDBMS</a:t>
           </a:r>
         </a:p>
       </dgm:t>
@@ -8756,7 +8756,7 @@
           </a:pPr>
           <a:r>
             <a:rPr lang="en-GB" sz="2200" kern="1200" dirty="0"/>
-            <a:t>Storing, loading and running the GNN for inference during application runtime</a:t>
+            <a:t>Storing, loading and running the GNN for inference during application runtime (inference)</a:t>
           </a:r>
         </a:p>
       </dsp:txBody>
@@ -8921,7 +8921,7 @@
           </a:pPr>
           <a:r>
             <a:rPr lang="en-GB" sz="2200" kern="1200" dirty="0"/>
-            <a:t>Schedule, running and tracking the GNN training runs and hyperparameter optimization</a:t>
+            <a:t>Schedule, running and tracking the GNN training runs and hyperparameter optimization to improve the model</a:t>
           </a:r>
         </a:p>
       </dsp:txBody>
@@ -9089,7 +9089,7 @@
           </a:pPr>
           <a:r>
             <a:rPr lang="en-GB" sz="2300" kern="1200" dirty="0"/>
-            <a:t>In order to access the needed data, the existing CSV-file is converted and stored in a RDBMS</a:t>
+            <a:t>In order to access the needed data from the application during inference, the existing CSV-file is converted and stored in a RDBMS</a:t>
           </a:r>
         </a:p>
       </dsp:txBody>
@@ -16810,7 +16810,7 @@
             <a:pPr rtl="0"/>
             <a:fld id="{705D51D2-ADCD-4092-BFAC-B3B920D83F85}" type="datetime1">
               <a:rPr lang="de-DE" smtClean="0"/>
-              <a:t>06.04.2026</a:t>
+              <a:t>09.04.2026</a:t>
             </a:fld>
             <a:endParaRPr lang="de-DE" dirty="0"/>
           </a:p>
@@ -16979,7 +16979,7 @@
             <a:fld id="{253EE615-04DF-4142-8B33-EF0FCE4F93E5}" type="datetime1">
               <a:rPr lang="de-DE" smtClean="0"/>
               <a:pPr/>
-              <a:t>06.04.2026</a:t>
+              <a:t>09.04.2026</a:t>
             </a:fld>
             <a:endParaRPr lang="de-DE" dirty="0"/>
           </a:p>
@@ -17616,7 +17616,7 @@
             <a:pPr rtl="0"/>
             <a:fld id="{88FC6F8F-5002-4D94-A3C0-B6AB2DF62D27}" type="datetime1">
               <a:rPr lang="de-DE" noProof="0" smtClean="0"/>
-              <a:t>06.04.2026</a:t>
+              <a:t>09.04.2026</a:t>
             </a:fld>
             <a:endParaRPr lang="de-DE" noProof="0" dirty="0"/>
           </a:p>
@@ -17822,7 +17822,7 @@
             <a:pPr rtl="0"/>
             <a:fld id="{8FFF26CF-3A7C-4631-A8BF-38458B0B5AD3}" type="datetime1">
               <a:rPr lang="de-DE" noProof="0" smtClean="0"/>
-              <a:t>06.04.2026</a:t>
+              <a:t>09.04.2026</a:t>
             </a:fld>
             <a:endParaRPr lang="de-DE" noProof="0" dirty="0"/>
           </a:p>
@@ -18001,7 +18001,7 @@
             <a:pPr rtl="0"/>
             <a:fld id="{5656F5FC-E12D-4883-A900-D8F749C16886}" type="datetime1">
               <a:rPr lang="de-DE" noProof="0" smtClean="0"/>
-              <a:t>06.04.2026</a:t>
+              <a:t>09.04.2026</a:t>
             </a:fld>
             <a:endParaRPr lang="de-DE" noProof="0" dirty="0"/>
           </a:p>
@@ -18205,7 +18205,7 @@
             <a:pPr rtl="0"/>
             <a:fld id="{AD11D247-BF25-4313-848F-0A6FFDC42CC3}" type="datetime1">
               <a:rPr lang="de-DE" noProof="0" smtClean="0"/>
-              <a:t>06.04.2026</a:t>
+              <a:t>09.04.2026</a:t>
             </a:fld>
             <a:endParaRPr lang="de-DE" noProof="0" dirty="0"/>
           </a:p>
@@ -27102,7 +27102,7 @@
             <a:pPr rtl="0"/>
             <a:fld id="{043CEAD4-1021-4B35-8BEC-0363D8DA6A57}" type="datetime1">
               <a:rPr lang="de-DE" noProof="0" smtClean="0"/>
-              <a:t>06.04.2026</a:t>
+              <a:t>09.04.2026</a:t>
             </a:fld>
             <a:endParaRPr lang="de-DE" noProof="0" dirty="0"/>
           </a:p>
@@ -27375,7 +27375,7 @@
             <a:pPr rtl="0"/>
             <a:fld id="{BE0DE884-BDB3-4445-9C7C-427638C7C80D}" type="datetime1">
               <a:rPr lang="de-DE" noProof="0" smtClean="0"/>
-              <a:t>06.04.2026</a:t>
+              <a:t>09.04.2026</a:t>
             </a:fld>
             <a:endParaRPr lang="de-DE" noProof="0" dirty="0"/>
           </a:p>
@@ -27771,7 +27771,7 @@
             <a:pPr rtl="0"/>
             <a:fld id="{24235473-FEB4-4673-9FA8-147CB48494B0}" type="datetime1">
               <a:rPr lang="de-DE" noProof="0" smtClean="0"/>
-              <a:t>06.04.2026</a:t>
+              <a:t>09.04.2026</a:t>
             </a:fld>
             <a:endParaRPr lang="de-DE" noProof="0" dirty="0"/>
           </a:p>
@@ -27888,7 +27888,7 @@
             <a:pPr rtl="0"/>
             <a:fld id="{DB72DBD2-9956-48DD-B433-972316F0D390}" type="datetime1">
               <a:rPr lang="de-DE" noProof="0" smtClean="0"/>
-              <a:t>06.04.2026</a:t>
+              <a:t>09.04.2026</a:t>
             </a:fld>
             <a:endParaRPr lang="de-DE" noProof="0" dirty="0"/>
           </a:p>
@@ -27981,7 +27981,7 @@
             <a:pPr rtl="0"/>
             <a:fld id="{7E7600A1-B4CA-4F63-8D09-F7DBA6E64CEA}" type="datetime1">
               <a:rPr lang="de-DE" noProof="0" smtClean="0"/>
-              <a:t>06.04.2026</a:t>
+              <a:t>09.04.2026</a:t>
             </a:fld>
             <a:endParaRPr lang="de-DE" noProof="0" dirty="0"/>
           </a:p>
@@ -28270,7 +28270,7 @@
             <a:pPr rtl="0"/>
             <a:fld id="{E723E022-A1A1-4E4C-B902-14F8D62BE84E}" type="datetime1">
               <a:rPr lang="de-DE" noProof="0" smtClean="0"/>
-              <a:t>06.04.2026</a:t>
+              <a:t>09.04.2026</a:t>
             </a:fld>
             <a:endParaRPr lang="de-DE" noProof="0" dirty="0"/>
           </a:p>
@@ -28550,7 +28550,7 @@
             <a:pPr rtl="0"/>
             <a:fld id="{01FB6D58-F84C-4882-B265-0A468AAE9816}" type="datetime1">
               <a:rPr lang="de-DE" noProof="0" smtClean="0"/>
-              <a:t>06.04.2026</a:t>
+              <a:t>09.04.2026</a:t>
             </a:fld>
             <a:endParaRPr lang="de-DE" noProof="0" dirty="0"/>
           </a:p>
@@ -28797,7 +28797,7 @@
             <a:pPr rtl="0"/>
             <a:fld id="{9E3617B5-9D3A-4290-B029-5215CF6190BB}" type="datetime1">
               <a:rPr lang="de-DE" noProof="0" smtClean="0"/>
-              <a:t>06.04.2026</a:t>
+              <a:t>09.04.2026</a:t>
             </a:fld>
             <a:endParaRPr lang="de-DE" noProof="0" dirty="0"/>
           </a:p>
@@ -30194,7 +30194,7 @@
             <p:ph idx="1"/>
             <p:extLst>
               <p:ext uri="{D42A27DB-BD31-4B8C-83A1-F6EECF244321}">
-                <p14:modId xmlns:p14="http://schemas.microsoft.com/office/powerpoint/2010/main" val="4026254023"/>
+                <p14:modId xmlns:p14="http://schemas.microsoft.com/office/powerpoint/2010/main" val="1925145454"/>
               </p:ext>
             </p:extLst>
           </p:nvPr>
@@ -30449,7 +30449,7 @@
             <p:ph idx="1"/>
             <p:extLst>
               <p:ext uri="{D42A27DB-BD31-4B8C-83A1-F6EECF244321}">
-                <p14:modId xmlns:p14="http://schemas.microsoft.com/office/powerpoint/2010/main" val="2071096414"/>
+                <p14:modId xmlns:p14="http://schemas.microsoft.com/office/powerpoint/2010/main" val="2349033657"/>
               </p:ext>
             </p:extLst>
           </p:nvPr>
@@ -30751,7 +30751,7 @@
             <p:ph idx="1"/>
             <p:extLst>
               <p:ext uri="{D42A27DB-BD31-4B8C-83A1-F6EECF244321}">
-                <p14:modId xmlns:p14="http://schemas.microsoft.com/office/powerpoint/2010/main" val="4231629927"/>
+                <p14:modId xmlns:p14="http://schemas.microsoft.com/office/powerpoint/2010/main" val="335840872"/>
               </p:ext>
             </p:extLst>
           </p:nvPr>
@@ -31746,6 +31746,23 @@
 </file>
 
 <file path=customXml/item1.xml><?xml version="1.0" encoding="utf-8"?>
+<p:properties xmlns:p="http://schemas.microsoft.com/office/2006/metadata/properties" xmlns:xsi="http://www.w3.org/2001/XMLSchema-instance" xmlns:pc="http://schemas.microsoft.com/office/infopath/2007/PartnerControls">
+  <documentManagement>
+    <MediaServiceKeyPoints xmlns="71af3243-3dd4-4a8d-8c0d-dd76da1f02a5" xsi:nil="true"/>
+  </documentManagement>
+</p:properties>
+</file>
+
+<file path=customXml/item2.xml><?xml version="1.0" encoding="utf-8"?>
+<?mso-contentType ?>
+<FormTemplates xmlns="http://schemas.microsoft.com/sharepoint/v3/contenttype/forms">
+  <Display>DocumentLibraryForm</Display>
+  <Edit>DocumentLibraryForm</Edit>
+  <New>DocumentLibraryForm</New>
+</FormTemplates>
+</file>
+
+<file path=customXml/item3.xml><?xml version="1.0" encoding="utf-8"?>
 <ct:contentTypeSchema xmlns:ct="http://schemas.microsoft.com/office/2006/metadata/contentType" xmlns:ma="http://schemas.microsoft.com/office/2006/metadata/properties/metaAttributes" ct:_="" ma:_="" ma:contentTypeName="Document" ma:contentTypeID="0x01010079F111ED35F8CC479449609E8A0923A6" ma:contentTypeVersion="11" ma:contentTypeDescription="Create a new document." ma:contentTypeScope="" ma:versionID="9677210f24a1be23c92c90fd886aa0aa">
   <xsd:schema xmlns:xsd="http://www.w3.org/2001/XMLSchema" xmlns:xs="http://www.w3.org/2001/XMLSchema" xmlns:p="http://schemas.microsoft.com/office/2006/metadata/properties" xmlns:ns2="71af3243-3dd4-4a8d-8c0d-dd76da1f02a5" xmlns:ns3="16c05727-aa75-4e4a-9b5f-8a80a1165891" targetNamespace="http://schemas.microsoft.com/office/2006/metadata/properties" ma:root="true" ma:fieldsID="60e05723c5c1908df1a1a4ebf11d344e" ns2:_="" ns3:_="">
     <xsd:import namespace="71af3243-3dd4-4a8d-8c0d-dd76da1f02a5"/>
@@ -31956,24 +31973,25 @@
 </ct:contentTypeSchema>
 </file>
 
-<file path=customXml/item2.xml><?xml version="1.0" encoding="utf-8"?>
-<?mso-contentType ?>
-<FormTemplates xmlns="http://schemas.microsoft.com/sharepoint/v3/contenttype/forms">
-  <Display>DocumentLibraryForm</Display>
-  <Edit>DocumentLibraryForm</Edit>
-  <New>DocumentLibraryForm</New>
-</FormTemplates>
+<file path=customXml/itemProps1.xml><?xml version="1.0" encoding="utf-8"?>
+<ds:datastoreItem xmlns:ds="http://schemas.openxmlformats.org/officeDocument/2006/customXml" ds:itemID="{788A2F88-55C5-4ED1-9541-807C65424763}">
+  <ds:schemaRefs>
+    <ds:schemaRef ds:uri="http://schemas.microsoft.com/office/2006/metadata/properties"/>
+    <ds:schemaRef ds:uri="http://schemas.microsoft.com/office/infopath/2007/PartnerControls"/>
+    <ds:schemaRef ds:uri="71af3243-3dd4-4a8d-8c0d-dd76da1f02a5"/>
+  </ds:schemaRefs>
+</ds:datastoreItem>
 </file>
 
-<file path=customXml/item3.xml><?xml version="1.0" encoding="utf-8"?>
-<p:properties xmlns:p="http://schemas.microsoft.com/office/2006/metadata/properties" xmlns:xsi="http://www.w3.org/2001/XMLSchema-instance" xmlns:pc="http://schemas.microsoft.com/office/infopath/2007/PartnerControls">
-  <documentManagement>
-    <MediaServiceKeyPoints xmlns="71af3243-3dd4-4a8d-8c0d-dd76da1f02a5" xsi:nil="true"/>
-  </documentManagement>
-</p:properties>
+<file path=customXml/itemProps2.xml><?xml version="1.0" encoding="utf-8"?>
+<ds:datastoreItem xmlns:ds="http://schemas.openxmlformats.org/officeDocument/2006/customXml" ds:itemID="{4F44C90D-2A62-4985-9618-3460247437B1}">
+  <ds:schemaRefs>
+    <ds:schemaRef ds:uri="http://schemas.microsoft.com/sharepoint/v3/contenttype/forms"/>
+  </ds:schemaRefs>
+</ds:datastoreItem>
 </file>
 
-<file path=customXml/itemProps1.xml><?xml version="1.0" encoding="utf-8"?>
+<file path=customXml/itemProps3.xml><?xml version="1.0" encoding="utf-8"?>
 <ds:datastoreItem xmlns:ds="http://schemas.openxmlformats.org/officeDocument/2006/customXml" ds:itemID="{B61EAB5F-88FC-4FAE-AE3C-037A3C365EB8}">
   <ds:schemaRefs>
     <ds:schemaRef ds:uri="http://schemas.microsoft.com/office/2006/metadata/contentType"/>
@@ -31990,22 +32008,4 @@
     <ds:schemaRef ds:uri="http://schemas.microsoft.com/internal/obd"/>
   </ds:schemaRefs>
 </ds:datastoreItem>
-</file>
-
-<file path=customXml/itemProps2.xml><?xml version="1.0" encoding="utf-8"?>
-<ds:datastoreItem xmlns:ds="http://schemas.openxmlformats.org/officeDocument/2006/customXml" ds:itemID="{4F44C90D-2A62-4985-9618-3460247437B1}">
-  <ds:schemaRefs>
-    <ds:schemaRef ds:uri="http://schemas.microsoft.com/sharepoint/v3/contenttype/forms"/>
-  </ds:schemaRefs>
-</ds:datastoreItem>
-</file>
-
-<file path=customXml/itemProps3.xml><?xml version="1.0" encoding="utf-8"?>
-<ds:datastoreItem xmlns:ds="http://schemas.openxmlformats.org/officeDocument/2006/customXml" ds:itemID="{788A2F88-55C5-4ED1-9541-807C65424763}">
-  <ds:schemaRefs>
-    <ds:schemaRef ds:uri="http://schemas.microsoft.com/office/2006/metadata/properties"/>
-    <ds:schemaRef ds:uri="http://schemas.microsoft.com/office/infopath/2007/PartnerControls"/>
-    <ds:schemaRef ds:uri="71af3243-3dd4-4a8d-8c0d-dd76da1f02a5"/>
-  </ds:schemaRefs>
-</ds:datastoreItem>
 </file>
</xml_diff>

<commit_message>
docu: update diagram, updated pitch deck
</commit_message>
<xml_diff>
--- a/project_documents/pitch_deck_cinematch.pptx
+++ b/project_documents/pitch_deck_cinematch.pptx
@@ -5,19 +5,20 @@
     <p:sldMasterId id="2147483648" r:id="rId4"/>
   </p:sldMasterIdLst>
   <p:notesMasterIdLst>
-    <p:notesMasterId r:id="rId12"/>
+    <p:notesMasterId r:id="rId13"/>
   </p:notesMasterIdLst>
   <p:handoutMasterIdLst>
-    <p:handoutMasterId r:id="rId13"/>
+    <p:handoutMasterId r:id="rId14"/>
   </p:handoutMasterIdLst>
   <p:sldIdLst>
     <p:sldId id="256" r:id="rId5"/>
     <p:sldId id="277" r:id="rId6"/>
     <p:sldId id="283" r:id="rId7"/>
     <p:sldId id="279" r:id="rId8"/>
-    <p:sldId id="282" r:id="rId9"/>
-    <p:sldId id="280" r:id="rId10"/>
-    <p:sldId id="281" r:id="rId11"/>
+    <p:sldId id="284" r:id="rId9"/>
+    <p:sldId id="282" r:id="rId10"/>
+    <p:sldId id="280" r:id="rId11"/>
+    <p:sldId id="281" r:id="rId12"/>
   </p:sldIdLst>
   <p:sldSz cx="12192000" cy="6858000"/>
   <p:notesSz cx="6858000" cy="9144000"/>
@@ -5435,7 +5436,7 @@
         <a:p>
           <a:r>
             <a:rPr lang="en-GB" dirty="0"/>
-            <a:t>Storing, loading and running the GNN for inference during application runtime (inference)</a:t>
+            <a:t>Storing, loading, and running the GNN for inference during application runtime (inference)</a:t>
           </a:r>
         </a:p>
       </dgm:t>
@@ -5471,7 +5472,7 @@
         <a:p>
           <a:r>
             <a:rPr lang="en-GB" dirty="0"/>
-            <a:t>Schedule, running and tracking the GNN training runs and hyperparameter optimization to improve the model</a:t>
+            <a:t>Schedule, running, and tracking the GNN training runs and hyperparameter optimization to improve the model</a:t>
           </a:r>
         </a:p>
       </dgm:t>
@@ -8756,7 +8757,7 @@
           </a:pPr>
           <a:r>
             <a:rPr lang="en-GB" sz="2200" kern="1200" dirty="0"/>
-            <a:t>Storing, loading and running the GNN for inference during application runtime (inference)</a:t>
+            <a:t>Storing, loading, and running the GNN for inference during application runtime (inference)</a:t>
           </a:r>
         </a:p>
       </dsp:txBody>
@@ -8921,7 +8922,7 @@
           </a:pPr>
           <a:r>
             <a:rPr lang="en-GB" sz="2200" kern="1200" dirty="0"/>
-            <a:t>Schedule, running and tracking the GNN training runs and hyperparameter optimization to improve the model</a:t>
+            <a:t>Schedule, running, and tracking the GNN training runs and hyperparameter optimization to improve the model</a:t>
           </a:r>
         </a:p>
       </dsp:txBody>
@@ -16810,7 +16811,7 @@
             <a:pPr rtl="0"/>
             <a:fld id="{705D51D2-ADCD-4092-BFAC-B3B920D83F85}" type="datetime1">
               <a:rPr lang="de-DE" smtClean="0"/>
-              <a:t>09.04.2026</a:t>
+              <a:t>19.04.2026</a:t>
             </a:fld>
             <a:endParaRPr lang="de-DE" dirty="0"/>
           </a:p>
@@ -16979,7 +16980,7 @@
             <a:fld id="{253EE615-04DF-4142-8B33-EF0FCE4F93E5}" type="datetime1">
               <a:rPr lang="de-DE" smtClean="0"/>
               <a:pPr/>
-              <a:t>09.04.2026</a:t>
+              <a:t>19.04.2026</a:t>
             </a:fld>
             <a:endParaRPr lang="de-DE" dirty="0"/>
           </a:p>
@@ -17616,7 +17617,7 @@
             <a:pPr rtl="0"/>
             <a:fld id="{88FC6F8F-5002-4D94-A3C0-B6AB2DF62D27}" type="datetime1">
               <a:rPr lang="de-DE" noProof="0" smtClean="0"/>
-              <a:t>09.04.2026</a:t>
+              <a:t>19.04.2026</a:t>
             </a:fld>
             <a:endParaRPr lang="de-DE" noProof="0" dirty="0"/>
           </a:p>
@@ -17822,7 +17823,7 @@
             <a:pPr rtl="0"/>
             <a:fld id="{8FFF26CF-3A7C-4631-A8BF-38458B0B5AD3}" type="datetime1">
               <a:rPr lang="de-DE" noProof="0" smtClean="0"/>
-              <a:t>09.04.2026</a:t>
+              <a:t>19.04.2026</a:t>
             </a:fld>
             <a:endParaRPr lang="de-DE" noProof="0" dirty="0"/>
           </a:p>
@@ -18001,7 +18002,7 @@
             <a:pPr rtl="0"/>
             <a:fld id="{5656F5FC-E12D-4883-A900-D8F749C16886}" type="datetime1">
               <a:rPr lang="de-DE" noProof="0" smtClean="0"/>
-              <a:t>09.04.2026</a:t>
+              <a:t>19.04.2026</a:t>
             </a:fld>
             <a:endParaRPr lang="de-DE" noProof="0" dirty="0"/>
           </a:p>
@@ -18205,7 +18206,7 @@
             <a:pPr rtl="0"/>
             <a:fld id="{AD11D247-BF25-4313-848F-0A6FFDC42CC3}" type="datetime1">
               <a:rPr lang="de-DE" noProof="0" smtClean="0"/>
-              <a:t>09.04.2026</a:t>
+              <a:t>19.04.2026</a:t>
             </a:fld>
             <a:endParaRPr lang="de-DE" noProof="0" dirty="0"/>
           </a:p>
@@ -27102,7 +27103,7 @@
             <a:pPr rtl="0"/>
             <a:fld id="{043CEAD4-1021-4B35-8BEC-0363D8DA6A57}" type="datetime1">
               <a:rPr lang="de-DE" noProof="0" smtClean="0"/>
-              <a:t>09.04.2026</a:t>
+              <a:t>19.04.2026</a:t>
             </a:fld>
             <a:endParaRPr lang="de-DE" noProof="0" dirty="0"/>
           </a:p>
@@ -27375,7 +27376,7 @@
             <a:pPr rtl="0"/>
             <a:fld id="{BE0DE884-BDB3-4445-9C7C-427638C7C80D}" type="datetime1">
               <a:rPr lang="de-DE" noProof="0" smtClean="0"/>
-              <a:t>09.04.2026</a:t>
+              <a:t>19.04.2026</a:t>
             </a:fld>
             <a:endParaRPr lang="de-DE" noProof="0" dirty="0"/>
           </a:p>
@@ -27771,7 +27772,7 @@
             <a:pPr rtl="0"/>
             <a:fld id="{24235473-FEB4-4673-9FA8-147CB48494B0}" type="datetime1">
               <a:rPr lang="de-DE" noProof="0" smtClean="0"/>
-              <a:t>09.04.2026</a:t>
+              <a:t>19.04.2026</a:t>
             </a:fld>
             <a:endParaRPr lang="de-DE" noProof="0" dirty="0"/>
           </a:p>
@@ -27888,7 +27889,7 @@
             <a:pPr rtl="0"/>
             <a:fld id="{DB72DBD2-9956-48DD-B433-972316F0D390}" type="datetime1">
               <a:rPr lang="de-DE" noProof="0" smtClean="0"/>
-              <a:t>09.04.2026</a:t>
+              <a:t>19.04.2026</a:t>
             </a:fld>
             <a:endParaRPr lang="de-DE" noProof="0" dirty="0"/>
           </a:p>
@@ -27981,7 +27982,7 @@
             <a:pPr rtl="0"/>
             <a:fld id="{7E7600A1-B4CA-4F63-8D09-F7DBA6E64CEA}" type="datetime1">
               <a:rPr lang="de-DE" noProof="0" smtClean="0"/>
-              <a:t>09.04.2026</a:t>
+              <a:t>19.04.2026</a:t>
             </a:fld>
             <a:endParaRPr lang="de-DE" noProof="0" dirty="0"/>
           </a:p>
@@ -28270,7 +28271,7 @@
             <a:pPr rtl="0"/>
             <a:fld id="{E723E022-A1A1-4E4C-B902-14F8D62BE84E}" type="datetime1">
               <a:rPr lang="de-DE" noProof="0" smtClean="0"/>
-              <a:t>09.04.2026</a:t>
+              <a:t>19.04.2026</a:t>
             </a:fld>
             <a:endParaRPr lang="de-DE" noProof="0" dirty="0"/>
           </a:p>
@@ -28550,7 +28551,7 @@
             <a:pPr rtl="0"/>
             <a:fld id="{01FB6D58-F84C-4882-B265-0A468AAE9816}" type="datetime1">
               <a:rPr lang="de-DE" noProof="0" smtClean="0"/>
-              <a:t>09.04.2026</a:t>
+              <a:t>19.04.2026</a:t>
             </a:fld>
             <a:endParaRPr lang="de-DE" noProof="0" dirty="0"/>
           </a:p>
@@ -28797,7 +28798,7 @@
             <a:pPr rtl="0"/>
             <a:fld id="{9E3617B5-9D3A-4290-B029-5215CF6190BB}" type="datetime1">
               <a:rPr lang="de-DE" noProof="0" smtClean="0"/>
-              <a:t>09.04.2026</a:t>
+              <a:t>19.04.2026</a:t>
             </a:fld>
             <a:endParaRPr lang="de-DE" noProof="0" dirty="0"/>
           </a:p>
@@ -30149,6 +30150,98 @@
       </p:grpSpPr>
       <p:sp>
         <p:nvSpPr>
+          <p:cNvPr id="2" name="Title 1">
+            <a:extLst>
+              <a:ext uri="{FF2B5EF4-FFF2-40B4-BE49-F238E27FC236}">
+                <a16:creationId xmlns:a16="http://schemas.microsoft.com/office/drawing/2014/main" id="{2ACEC8AC-AACB-2A03-C75B-08AE25D9E275}"/>
+              </a:ext>
+            </a:extLst>
+          </p:cNvPr>
+          <p:cNvSpPr>
+            <a:spLocks noGrp="1"/>
+          </p:cNvSpPr>
+          <p:nvPr>
+            <p:ph type="title"/>
+          </p:nvPr>
+        </p:nvSpPr>
+        <p:spPr/>
+        <p:txBody>
+          <a:bodyPr>
+            <a:normAutofit fontScale="90000"/>
+          </a:bodyPr>
+          <a:lstStyle/>
+          <a:p>
+            <a:r>
+              <a:rPr lang="en-GB" dirty="0"/>
+              <a:t>System architecture</a:t>
+            </a:r>
+          </a:p>
+        </p:txBody>
+      </p:sp>
+      <p:pic>
+        <p:nvPicPr>
+          <p:cNvPr id="20" name="Content Placeholder 19">
+            <a:extLst>
+              <a:ext uri="{FF2B5EF4-FFF2-40B4-BE49-F238E27FC236}">
+                <a16:creationId xmlns:a16="http://schemas.microsoft.com/office/drawing/2014/main" id="{908212AE-7E94-3D13-1B2D-18A15E215C20}"/>
+              </a:ext>
+            </a:extLst>
+          </p:cNvPr>
+          <p:cNvPicPr>
+            <a:picLocks noGrp="1" noChangeAspect="1"/>
+          </p:cNvPicPr>
+          <p:nvPr>
+            <p:ph idx="1"/>
+          </p:nvPr>
+        </p:nvPicPr>
+        <p:blipFill>
+          <a:blip r:embed="rId2"/>
+          <a:stretch>
+            <a:fillRect/>
+          </a:stretch>
+        </p:blipFill>
+        <p:spPr>
+          <a:xfrm>
+            <a:off x="2457991" y="1586938"/>
+            <a:ext cx="7276017" cy="4992235"/>
+          </a:xfrm>
+          <a:prstGeom prst="rect">
+            <a:avLst/>
+          </a:prstGeom>
+        </p:spPr>
+      </p:pic>
+    </p:spTree>
+    <p:extLst>
+      <p:ext uri="{BB962C8B-B14F-4D97-AF65-F5344CB8AC3E}">
+        <p14:creationId xmlns:p14="http://schemas.microsoft.com/office/powerpoint/2010/main" val="2886663419"/>
+      </p:ext>
+    </p:extLst>
+  </p:cSld>
+  <p:clrMapOvr>
+    <a:masterClrMapping/>
+  </p:clrMapOvr>
+</p:sld>
+</file>
+
+<file path=ppt/slides/slide6.xml><?xml version="1.0" encoding="utf-8"?>
+<p:sld xmlns:a="http://schemas.openxmlformats.org/drawingml/2006/main" xmlns:r="http://schemas.openxmlformats.org/officeDocument/2006/relationships" xmlns:p="http://schemas.openxmlformats.org/presentationml/2006/main">
+  <p:cSld>
+    <p:spTree>
+      <p:nvGrpSpPr>
+        <p:cNvPr id="1" name=""/>
+        <p:cNvGrpSpPr/>
+        <p:nvPr/>
+      </p:nvGrpSpPr>
+      <p:grpSpPr>
+        <a:xfrm>
+          <a:off x="0" y="0"/>
+          <a:ext cx="0" cy="0"/>
+          <a:chOff x="0" y="0"/>
+          <a:chExt cx="0" cy="0"/>
+        </a:xfrm>
+      </p:grpSpPr>
+      <p:sp>
+        <p:nvSpPr>
           <p:cNvPr id="2" name="Titel 1">
             <a:extLst>
               <a:ext uri="{FF2B5EF4-FFF2-40B4-BE49-F238E27FC236}">
@@ -30194,7 +30287,7 @@
             <p:ph idx="1"/>
             <p:extLst>
               <p:ext uri="{D42A27DB-BD31-4B8C-83A1-F6EECF244321}">
-                <p14:modId xmlns:p14="http://schemas.microsoft.com/office/powerpoint/2010/main" val="1925145454"/>
+                <p14:modId xmlns:p14="http://schemas.microsoft.com/office/powerpoint/2010/main" val="4136086023"/>
               </p:ext>
             </p:extLst>
           </p:nvPr>
@@ -30385,7 +30478,7 @@
 </p:sld>
 </file>
 
-<file path=ppt/slides/slide6.xml><?xml version="1.0" encoding="utf-8"?>
+<file path=ppt/slides/slide7.xml><?xml version="1.0" encoding="utf-8"?>
 <p:sld xmlns:a="http://schemas.openxmlformats.org/drawingml/2006/main" xmlns:r="http://schemas.openxmlformats.org/officeDocument/2006/relationships" xmlns:p="http://schemas.openxmlformats.org/presentationml/2006/main">
   <p:cSld>
     <p:spTree>
@@ -30683,7 +30776,7 @@
 </p:sld>
 </file>
 
-<file path=ppt/slides/slide7.xml><?xml version="1.0" encoding="utf-8"?>
+<file path=ppt/slides/slide8.xml><?xml version="1.0" encoding="utf-8"?>
 <p:sld xmlns:a="http://schemas.openxmlformats.org/drawingml/2006/main" xmlns:r="http://schemas.openxmlformats.org/officeDocument/2006/relationships" xmlns:p="http://schemas.openxmlformats.org/presentationml/2006/main">
   <p:cSld>
     <p:spTree>
@@ -31746,23 +31839,6 @@
 </file>
 
 <file path=customXml/item1.xml><?xml version="1.0" encoding="utf-8"?>
-<p:properties xmlns:p="http://schemas.microsoft.com/office/2006/metadata/properties" xmlns:xsi="http://www.w3.org/2001/XMLSchema-instance" xmlns:pc="http://schemas.microsoft.com/office/infopath/2007/PartnerControls">
-  <documentManagement>
-    <MediaServiceKeyPoints xmlns="71af3243-3dd4-4a8d-8c0d-dd76da1f02a5" xsi:nil="true"/>
-  </documentManagement>
-</p:properties>
-</file>
-
-<file path=customXml/item2.xml><?xml version="1.0" encoding="utf-8"?>
-<?mso-contentType ?>
-<FormTemplates xmlns="http://schemas.microsoft.com/sharepoint/v3/contenttype/forms">
-  <Display>DocumentLibraryForm</Display>
-  <Edit>DocumentLibraryForm</Edit>
-  <New>DocumentLibraryForm</New>
-</FormTemplates>
-</file>
-
-<file path=customXml/item3.xml><?xml version="1.0" encoding="utf-8"?>
 <ct:contentTypeSchema xmlns:ct="http://schemas.microsoft.com/office/2006/metadata/contentType" xmlns:ma="http://schemas.microsoft.com/office/2006/metadata/properties/metaAttributes" ct:_="" ma:_="" ma:contentTypeName="Document" ma:contentTypeID="0x01010079F111ED35F8CC479449609E8A0923A6" ma:contentTypeVersion="11" ma:contentTypeDescription="Create a new document." ma:contentTypeScope="" ma:versionID="9677210f24a1be23c92c90fd886aa0aa">
   <xsd:schema xmlns:xsd="http://www.w3.org/2001/XMLSchema" xmlns:xs="http://www.w3.org/2001/XMLSchema" xmlns:p="http://schemas.microsoft.com/office/2006/metadata/properties" xmlns:ns2="71af3243-3dd4-4a8d-8c0d-dd76da1f02a5" xmlns:ns3="16c05727-aa75-4e4a-9b5f-8a80a1165891" targetNamespace="http://schemas.microsoft.com/office/2006/metadata/properties" ma:root="true" ma:fieldsID="60e05723c5c1908df1a1a4ebf11d344e" ns2:_="" ns3:_="">
     <xsd:import namespace="71af3243-3dd4-4a8d-8c0d-dd76da1f02a5"/>
@@ -31973,25 +32049,24 @@
 </ct:contentTypeSchema>
 </file>
 
-<file path=customXml/itemProps1.xml><?xml version="1.0" encoding="utf-8"?>
-<ds:datastoreItem xmlns:ds="http://schemas.openxmlformats.org/officeDocument/2006/customXml" ds:itemID="{788A2F88-55C5-4ED1-9541-807C65424763}">
-  <ds:schemaRefs>
-    <ds:schemaRef ds:uri="http://schemas.microsoft.com/office/2006/metadata/properties"/>
-    <ds:schemaRef ds:uri="http://schemas.microsoft.com/office/infopath/2007/PartnerControls"/>
-    <ds:schemaRef ds:uri="71af3243-3dd4-4a8d-8c0d-dd76da1f02a5"/>
-  </ds:schemaRefs>
-</ds:datastoreItem>
+<file path=customXml/item2.xml><?xml version="1.0" encoding="utf-8"?>
+<?mso-contentType ?>
+<FormTemplates xmlns="http://schemas.microsoft.com/sharepoint/v3/contenttype/forms">
+  <Display>DocumentLibraryForm</Display>
+  <Edit>DocumentLibraryForm</Edit>
+  <New>DocumentLibraryForm</New>
+</FormTemplates>
 </file>
 
-<file path=customXml/itemProps2.xml><?xml version="1.0" encoding="utf-8"?>
-<ds:datastoreItem xmlns:ds="http://schemas.openxmlformats.org/officeDocument/2006/customXml" ds:itemID="{4F44C90D-2A62-4985-9618-3460247437B1}">
-  <ds:schemaRefs>
-    <ds:schemaRef ds:uri="http://schemas.microsoft.com/sharepoint/v3/contenttype/forms"/>
-  </ds:schemaRefs>
-</ds:datastoreItem>
+<file path=customXml/item3.xml><?xml version="1.0" encoding="utf-8"?>
+<p:properties xmlns:p="http://schemas.microsoft.com/office/2006/metadata/properties" xmlns:xsi="http://www.w3.org/2001/XMLSchema-instance" xmlns:pc="http://schemas.microsoft.com/office/infopath/2007/PartnerControls">
+  <documentManagement>
+    <MediaServiceKeyPoints xmlns="71af3243-3dd4-4a8d-8c0d-dd76da1f02a5" xsi:nil="true"/>
+  </documentManagement>
+</p:properties>
 </file>
 
-<file path=customXml/itemProps3.xml><?xml version="1.0" encoding="utf-8"?>
+<file path=customXml/itemProps1.xml><?xml version="1.0" encoding="utf-8"?>
 <ds:datastoreItem xmlns:ds="http://schemas.openxmlformats.org/officeDocument/2006/customXml" ds:itemID="{B61EAB5F-88FC-4FAE-AE3C-037A3C365EB8}">
   <ds:schemaRefs>
     <ds:schemaRef ds:uri="http://schemas.microsoft.com/office/2006/metadata/contentType"/>
@@ -32008,4 +32083,22 @@
     <ds:schemaRef ds:uri="http://schemas.microsoft.com/internal/obd"/>
   </ds:schemaRefs>
 </ds:datastoreItem>
+</file>
+
+<file path=customXml/itemProps2.xml><?xml version="1.0" encoding="utf-8"?>
+<ds:datastoreItem xmlns:ds="http://schemas.openxmlformats.org/officeDocument/2006/customXml" ds:itemID="{4F44C90D-2A62-4985-9618-3460247437B1}">
+  <ds:schemaRefs>
+    <ds:schemaRef ds:uri="http://schemas.microsoft.com/sharepoint/v3/contenttype/forms"/>
+  </ds:schemaRefs>
+</ds:datastoreItem>
+</file>
+
+<file path=customXml/itemProps3.xml><?xml version="1.0" encoding="utf-8"?>
+<ds:datastoreItem xmlns:ds="http://schemas.openxmlformats.org/officeDocument/2006/customXml" ds:itemID="{788A2F88-55C5-4ED1-9541-807C65424763}">
+  <ds:schemaRefs>
+    <ds:schemaRef ds:uri="http://schemas.microsoft.com/office/2006/metadata/properties"/>
+    <ds:schemaRef ds:uri="http://schemas.microsoft.com/office/infopath/2007/PartnerControls"/>
+    <ds:schemaRef ds:uri="71af3243-3dd4-4a8d-8c0d-dd76da1f02a5"/>
+  </ds:schemaRefs>
+</ds:datastoreItem>
 </file>
</xml_diff>